<commit_message>
Swap jargon 'rail' -> 'system' across Mara deck, memo, and runbook
Co-Authored-By: Claude Opus 4.8 <noreply@anthropic.com>
</commit_message>
<xml_diff>
--- a/Cleared_live_for_Mara_v2.pptx
+++ b/Cleared_live_for_Mara_v2.pptx
@@ -2056,6 +2056,10 @@
             <a:prstDash val="solid"/>
           </a:ln>
         </p:spPr>
+        <p:txBody>
+          <a:bodyPr/>
+          <a:p/>
+        </p:txBody>
       </p:sp>
       <p:sp>
         <p:nvSpPr>
@@ -2076,6 +2080,10 @@
           </a:solidFill>
           <a:ln/>
         </p:spPr>
+        <p:txBody>
+          <a:bodyPr/>
+          <a:p/>
+        </p:txBody>
       </p:sp>
       <p:sp>
         <p:nvSpPr>
@@ -2181,6 +2189,10 @@
             <a:prstDash val="solid"/>
           </a:ln>
         </p:spPr>
+        <p:txBody>
+          <a:bodyPr/>
+          <a:p/>
+        </p:txBody>
       </p:sp>
       <p:sp>
         <p:nvSpPr>
@@ -2201,6 +2213,10 @@
           </a:solidFill>
           <a:ln/>
         </p:spPr>
+        <p:txBody>
+          <a:bodyPr/>
+          <a:p/>
+        </p:txBody>
       </p:sp>
       <p:sp>
         <p:nvSpPr>
@@ -2306,6 +2322,10 @@
             <a:prstDash val="solid"/>
           </a:ln>
         </p:spPr>
+        <p:txBody>
+          <a:bodyPr/>
+          <a:p/>
+        </p:txBody>
       </p:sp>
       <p:sp>
         <p:nvSpPr>
@@ -2326,6 +2346,10 @@
           </a:solidFill>
           <a:ln/>
         </p:spPr>
+        <p:txBody>
+          <a:bodyPr/>
+          <a:p/>
+        </p:txBody>
       </p:sp>
       <p:sp>
         <p:nvSpPr>
@@ -2431,6 +2455,10 @@
             <a:prstDash val="solid"/>
           </a:ln>
         </p:spPr>
+        <p:txBody>
+          <a:bodyPr/>
+          <a:p/>
+        </p:txBody>
       </p:sp>
       <p:sp>
         <p:nvSpPr>
@@ -2451,6 +2479,10 @@
           </a:solidFill>
           <a:ln/>
         </p:spPr>
+        <p:txBody>
+          <a:bodyPr/>
+          <a:p/>
+        </p:txBody>
       </p:sp>
       <p:sp>
         <p:nvSpPr>
@@ -2665,7 +2697,7 @@
                 <a:ea typeface="Cambria" pitchFamily="34" charset="-122"/>
                 <a:cs typeface="Cambria" pitchFamily="34" charset="-120"/>
               </a:rPr>
-              <a:t>One rail.</a:t>
+              <a:t>One system.</a:t>
             </a:r>
             <a:endParaRPr lang="en-US" sz="4000" dirty="0"/>
           </a:p>
@@ -2727,7 +2759,7 @@
                 <a:ea typeface="Calibri" pitchFamily="34" charset="-122"/>
                 <a:cs typeface="Calibri" pitchFamily="34" charset="-120"/>
               </a:rPr>
-              <a:t>Platforms intake the project. Labels issue the waiver. One rail, one AI — drafted, negotiated, and tracked to signed.</a:t>
+              <a:t>Platforms intake the project. Labels issue the waiver. One system, one AI — drafted, negotiated, and tracked to signed.</a:t>
             </a:r>
             <a:endParaRPr lang="en-US" sz="1900" dirty="0"/>
           </a:p>
@@ -3132,6 +3164,10 @@
             </a:outerShdw>
           </a:effectLst>
         </p:spPr>
+        <p:txBody>
+          <a:bodyPr/>
+          <a:p/>
+        </p:txBody>
       </p:sp>
       <p:sp>
         <p:nvSpPr>
@@ -3159,6 +3195,10 @@
             </a:outerShdw>
           </a:effectLst>
         </p:spPr>
+        <p:txBody>
+          <a:bodyPr/>
+          <a:p/>
+        </p:txBody>
       </p:sp>
       <p:sp>
         <p:nvSpPr>
@@ -3313,6 +3353,10 @@
             </a:outerShdw>
           </a:effectLst>
         </p:spPr>
+        <p:txBody>
+          <a:bodyPr/>
+          <a:p/>
+        </p:txBody>
       </p:sp>
       <p:sp>
         <p:nvSpPr>
@@ -3340,6 +3384,10 @@
             </a:outerShdw>
           </a:effectLst>
         </p:spPr>
+        <p:txBody>
+          <a:bodyPr/>
+          <a:p/>
+        </p:txBody>
       </p:sp>
       <p:sp>
         <p:nvSpPr>
@@ -3632,6 +3680,10 @@
             </a:outerShdw>
           </a:effectLst>
         </p:spPr>
+        <p:txBody>
+          <a:bodyPr/>
+          <a:p/>
+        </p:txBody>
       </p:sp>
       <p:pic>
         <p:nvPicPr>
@@ -3685,6 +3737,10 @@
             </a:outerShdw>
           </a:effectLst>
         </p:spPr>
+        <p:txBody>
+          <a:bodyPr/>
+          <a:p/>
+        </p:txBody>
       </p:sp>
       <p:sp>
         <p:nvSpPr>
@@ -3916,6 +3972,10 @@
             </a:outerShdw>
           </a:effectLst>
         </p:spPr>
+        <p:txBody>
+          <a:bodyPr/>
+          <a:p/>
+        </p:txBody>
       </p:sp>
       <p:pic>
         <p:nvPicPr>
@@ -3969,6 +4029,10 @@
             </a:outerShdw>
           </a:effectLst>
         </p:spPr>
+        <p:txBody>
+          <a:bodyPr/>
+          <a:p/>
+        </p:txBody>
       </p:sp>
       <p:sp>
         <p:nvSpPr>

</xml_diff>